<commit_message>
Move the games note to the sources slide and update its figure
Follows the comment in the source deck: the "А ещё" block leaves the
volumes slide for the sources slide, and its figure changes from
"197 млн руб. заработали через запуск игр для Розницы и ММБ" to
"8 млн человек сыграют в игры в 2026 году".

On the sources slide the note takes the product panel's free right column,
set off by a hairline rather than a card so the panel keeps one background;
its last line shares a baseline with the last product in the lists. The gem
moves to the volumes slide, which now carries three KPI cards only: their
contents are optically centred, figures go up to 104px, and the gem anchors
the lower right opposite the star.

Drops the accent-bar primitives (Arc, red tint tokens) that no longer have
a user.

Co-Authored-By: Claude Opus 5 <noreply@anthropic.com>
Claude-Session: https://claude.ai/code/session_01JKtZ8EiEWqtahhK746uvUw
</commit_message>
<xml_diff>
--- a/alfabank-redesign/dist/alfa-online-sales-redesign.pptx
+++ b/alfabank-redesign/dist/alfa-online-sales-redesign.pptx
@@ -6834,9 +6834,44 @@
           </a:p>
         </p:txBody>
       </p:sp>
+      <p:cxnSp>
+        <p:nvCxnSpPr>
+          <p:cNvPr id="105" name="Connector 104"/>
+          <p:cNvCxnSpPr/>
+          <p:nvPr/>
+        </p:nvCxnSpPr>
+        <p:spPr>
+          <a:xfrm>
+            <a:off x="8826500" y="4216400"/>
+            <a:ext cx="0" cy="1854200"/>
+          </a:xfrm>
+          <a:prstGeom prst="line">
+            <a:avLst/>
+          </a:prstGeom>
+          <a:ln w="6350">
+            <a:solidFill>
+              <a:srgbClr val="DCDCE2"/>
+            </a:solidFill>
+          </a:ln>
+        </p:spPr>
+        <p:style>
+          <a:lnRef idx="2">
+            <a:schemeClr val="accent1"/>
+          </a:lnRef>
+          <a:fillRef idx="0">
+            <a:schemeClr val="accent1"/>
+          </a:fillRef>
+          <a:effectRef idx="1">
+            <a:schemeClr val="accent1"/>
+          </a:effectRef>
+          <a:fontRef idx="minor">
+            <a:schemeClr val="tx1"/>
+          </a:fontRef>
+        </p:style>
+      </p:cxnSp>
       <p:pic>
         <p:nvPicPr>
-          <p:cNvPr id="105" name="Picture 104" descr="gem.png"/>
+          <p:cNvPr id="106" name="Picture 105" descr="trophy.png"/>
           <p:cNvPicPr>
             <a:picLocks noChangeAspect="1"/>
           </p:cNvPicPr>
@@ -6850,8 +6885,8 @@
         </p:blipFill>
         <p:spPr>
           <a:xfrm>
-            <a:off x="9575800" y="4838700"/>
-            <a:ext cx="1549400" cy="1220377"/>
+            <a:off x="9169400" y="4292600"/>
+            <a:ext cx="711200" cy="711200"/>
           </a:xfrm>
           <a:prstGeom prst="rect">
             <a:avLst/>
@@ -6860,7 +6895,147 @@
       </p:pic>
       <p:sp>
         <p:nvSpPr>
-          <p:cNvPr id="106" name="TextBox 105"/>
+          <p:cNvPr id="107" name="TextBox 106"/>
+          <p:cNvSpPr txBox="1"/>
+          <p:nvPr/>
+        </p:nvSpPr>
+        <p:spPr>
+          <a:xfrm>
+            <a:off x="9169400" y="5255936"/>
+            <a:ext cx="516062" cy="160020"/>
+          </a:xfrm>
+          <a:prstGeom prst="rect">
+            <a:avLst/>
+          </a:prstGeom>
+          <a:noFill/>
+        </p:spPr>
+        <p:txBody>
+          <a:bodyPr wrap="none" lIns="0" rIns="0" tIns="0" bIns="0" anchor="t">
+            <a:noAutofit/>
+          </a:bodyPr>
+          <a:lstStyle/>
+          <a:p>
+            <a:pPr algn="l"/>
+            <a:r>
+              <a:rPr sz="900" b="1" spc="126">
+                <a:solidFill>
+                  <a:srgbClr val="EF3124"/>
+                </a:solidFill>
+                <a:latin typeface="Arial"/>
+              </a:rPr>
+              <a:t>А ЕЩЁ</a:t>
+            </a:r>
+          </a:p>
+        </p:txBody>
+      </p:sp>
+      <p:sp>
+        <p:nvSpPr>
+          <p:cNvPr id="108" name="TextBox 107"/>
+          <p:cNvSpPr txBox="1"/>
+          <p:nvPr/>
+        </p:nvSpPr>
+        <p:spPr>
+          <a:xfrm>
+            <a:off x="9169400" y="5384566"/>
+            <a:ext cx="616692" cy="746760"/>
+          </a:xfrm>
+          <a:prstGeom prst="rect">
+            <a:avLst/>
+          </a:prstGeom>
+          <a:noFill/>
+        </p:spPr>
+        <p:txBody>
+          <a:bodyPr wrap="none" lIns="0" rIns="0" tIns="0" bIns="0" anchor="t">
+            <a:noAutofit/>
+          </a:bodyPr>
+          <a:lstStyle/>
+          <a:p>
+            <a:pPr algn="l"/>
+            <a:r>
+              <a:rPr sz="4200" b="1">
+                <a:solidFill>
+                  <a:srgbClr val="EF3124"/>
+                </a:solidFill>
+                <a:latin typeface="Arial"/>
+              </a:rPr>
+              <a:t>8</a:t>
+            </a:r>
+          </a:p>
+        </p:txBody>
+      </p:sp>
+      <p:sp>
+        <p:nvSpPr>
+          <p:cNvPr id="109" name="TextBox 108"/>
+          <p:cNvSpPr txBox="1"/>
+          <p:nvPr/>
+        </p:nvSpPr>
+        <p:spPr>
+          <a:xfrm>
+            <a:off x="9554952" y="5706455"/>
+            <a:ext cx="1228782" cy="248920"/>
+          </a:xfrm>
+          <a:prstGeom prst="rect">
+            <a:avLst/>
+          </a:prstGeom>
+          <a:noFill/>
+        </p:spPr>
+        <p:txBody>
+          <a:bodyPr wrap="none" lIns="0" rIns="0" tIns="0" bIns="0" anchor="t">
+            <a:noAutofit/>
+          </a:bodyPr>
+          <a:lstStyle/>
+          <a:p>
+            <a:pPr algn="l"/>
+            <a:r>
+              <a:rPr sz="1400" b="1">
+                <a:solidFill>
+                  <a:srgbClr val="EF3124"/>
+                </a:solidFill>
+                <a:latin typeface="Arial"/>
+              </a:rPr>
+              <a:t>млн человек</a:t>
+            </a:r>
+          </a:p>
+        </p:txBody>
+      </p:sp>
+      <p:sp>
+        <p:nvSpPr>
+          <p:cNvPr id="110" name="TextBox 109"/>
+          <p:cNvSpPr txBox="1"/>
+          <p:nvPr/>
+        </p:nvSpPr>
+        <p:spPr>
+          <a:xfrm>
+            <a:off x="9169400" y="6006440"/>
+            <a:ext cx="1699605" cy="177800"/>
+          </a:xfrm>
+          <a:prstGeom prst="rect">
+            <a:avLst/>
+          </a:prstGeom>
+          <a:noFill/>
+        </p:spPr>
+        <p:txBody>
+          <a:bodyPr wrap="none" lIns="0" rIns="0" tIns="0" bIns="0" anchor="t">
+            <a:noAutofit/>
+          </a:bodyPr>
+          <a:lstStyle/>
+          <a:p>
+            <a:pPr algn="l"/>
+            <a:r>
+              <a:rPr sz="1000" b="0">
+                <a:solidFill>
+                  <a:srgbClr val="1D1D1D"/>
+                </a:solidFill>
+                <a:latin typeface="Arial"/>
+              </a:rPr>
+              <a:t>сыграют в игры в 2026 году</a:t>
+            </a:r>
+          </a:p>
+        </p:txBody>
+      </p:sp>
+      <p:sp>
+        <p:nvSpPr>
+          <p:cNvPr id="111" name="TextBox 110"/>
           <p:cNvSpPr txBox="1"/>
           <p:nvPr/>
         </p:nvSpPr>
@@ -7045,12 +7220,12 @@
         </p:nvSpPr>
         <p:spPr>
           <a:xfrm>
-            <a:off x="508000" y="1841500"/>
-            <a:ext cx="3556000" cy="2032000"/>
+            <a:off x="508000" y="2133600"/>
+            <a:ext cx="3556000" cy="2438400"/>
           </a:xfrm>
           <a:prstGeom prst="roundRect">
             <a:avLst>
-              <a:gd name="adj" fmla="val 8750"/>
+              <a:gd name="adj" fmla="val 7291"/>
             </a:avLst>
           </a:prstGeom>
           <a:solidFill>
@@ -7093,23 +7268,23 @@
         </p:nvSpPr>
         <p:spPr>
           <a:xfrm>
-            <a:off x="787400" y="2140590"/>
-            <a:ext cx="1569184" cy="853440"/>
-          </a:xfrm>
-          <a:prstGeom prst="rect">
-            <a:avLst/>
-          </a:prstGeom>
-          <a:noFill/>
-        </p:spPr>
-        <p:txBody>
-          <a:bodyPr wrap="none" lIns="0" rIns="0" tIns="0" bIns="0" anchor="t">
-            <a:noAutofit/>
-          </a:bodyPr>
-          <a:lstStyle/>
-          <a:p>
-            <a:pPr algn="l"/>
-            <a:r>
-              <a:rPr sz="4800" b="1">
+            <a:off x="787400" y="2539106"/>
+            <a:ext cx="1699950" cy="924560"/>
+          </a:xfrm>
+          <a:prstGeom prst="rect">
+            <a:avLst/>
+          </a:prstGeom>
+          <a:noFill/>
+        </p:spPr>
+        <p:txBody>
+          <a:bodyPr wrap="none" lIns="0" rIns="0" tIns="0" bIns="0" anchor="t">
+            <a:noAutofit/>
+          </a:bodyPr>
+          <a:lstStyle/>
+          <a:p>
+            <a:pPr algn="l"/>
+            <a:r>
+              <a:rPr sz="5200" b="1">
                 <a:solidFill>
                   <a:srgbClr val="EF3124"/>
                 </a:solidFill>
@@ -7128,7 +7303,7 @@
         </p:nvSpPr>
         <p:spPr>
           <a:xfrm>
-            <a:off x="2079724" y="2519959"/>
+            <a:off x="2180010" y="2964459"/>
             <a:ext cx="491300" cy="266700"/>
           </a:xfrm>
           <a:prstGeom prst="rect">
@@ -7163,7 +7338,7 @@
         </p:nvCxnSpPr>
         <p:spPr>
           <a:xfrm>
-            <a:off x="787400" y="3009900"/>
+            <a:off x="787400" y="3505200"/>
             <a:ext cx="2997200" cy="0"/>
           </a:xfrm>
           <a:prstGeom prst="line">
@@ -7198,7 +7373,7 @@
         </p:nvSpPr>
         <p:spPr>
           <a:xfrm>
-            <a:off x="787400" y="3128355"/>
+            <a:off x="787400" y="3649055"/>
             <a:ext cx="2350710" cy="248920"/>
           </a:xfrm>
           <a:prstGeom prst="rect">
@@ -7233,12 +7408,12 @@
         </p:nvSpPr>
         <p:spPr>
           <a:xfrm>
-            <a:off x="4318000" y="1841500"/>
-            <a:ext cx="3556000" cy="2032000"/>
+            <a:off x="4318000" y="2133600"/>
+            <a:ext cx="3556000" cy="2438400"/>
           </a:xfrm>
           <a:prstGeom prst="roundRect">
             <a:avLst>
-              <a:gd name="adj" fmla="val 8750"/>
+              <a:gd name="adj" fmla="val 7291"/>
             </a:avLst>
           </a:prstGeom>
           <a:solidFill>
@@ -7281,23 +7456,23 @@
         </p:nvSpPr>
         <p:spPr>
           <a:xfrm>
-            <a:off x="4597400" y="2140590"/>
-            <a:ext cx="1738848" cy="853440"/>
-          </a:xfrm>
-          <a:prstGeom prst="rect">
-            <a:avLst/>
-          </a:prstGeom>
-          <a:noFill/>
-        </p:spPr>
-        <p:txBody>
-          <a:bodyPr wrap="none" lIns="0" rIns="0" tIns="0" bIns="0" anchor="t">
-            <a:noAutofit/>
-          </a:bodyPr>
-          <a:lstStyle/>
-          <a:p>
-            <a:pPr algn="l"/>
-            <a:r>
-              <a:rPr sz="4800" b="1">
+            <a:off x="4597400" y="2539106"/>
+            <a:ext cx="1883752" cy="924560"/>
+          </a:xfrm>
+          <a:prstGeom prst="rect">
+            <a:avLst/>
+          </a:prstGeom>
+          <a:noFill/>
+        </p:spPr>
+        <p:txBody>
+          <a:bodyPr wrap="none" lIns="0" rIns="0" tIns="0" bIns="0" anchor="t">
+            <a:noAutofit/>
+          </a:bodyPr>
+          <a:lstStyle/>
+          <a:p>
+            <a:pPr algn="l"/>
+            <a:r>
+              <a:rPr sz="5200" b="1">
                 <a:solidFill>
                   <a:srgbClr val="EF3124"/>
                 </a:solidFill>
@@ -7316,7 +7491,7 @@
         </p:nvSpPr>
         <p:spPr>
           <a:xfrm>
-            <a:off x="6059388" y="2519959"/>
+            <a:off x="6173812" y="2964459"/>
             <a:ext cx="1059359" cy="266700"/>
           </a:xfrm>
           <a:prstGeom prst="rect">
@@ -7351,7 +7526,7 @@
         </p:nvCxnSpPr>
         <p:spPr>
           <a:xfrm>
-            <a:off x="4597400" y="3009900"/>
+            <a:off x="4597400" y="3505200"/>
             <a:ext cx="2997200" cy="0"/>
           </a:xfrm>
           <a:prstGeom prst="line">
@@ -7386,7 +7561,7 @@
         </p:nvSpPr>
         <p:spPr>
           <a:xfrm>
-            <a:off x="4597400" y="3128355"/>
+            <a:off x="4597400" y="3649055"/>
             <a:ext cx="2803979" cy="248920"/>
           </a:xfrm>
           <a:prstGeom prst="rect">
@@ -7421,7 +7596,7 @@
         </p:nvSpPr>
         <p:spPr>
           <a:xfrm>
-            <a:off x="4597400" y="3466440"/>
+            <a:off x="4597400" y="4012540"/>
             <a:ext cx="970471" cy="177800"/>
           </a:xfrm>
           <a:prstGeom prst="rect">
@@ -7456,12 +7631,12 @@
         </p:nvSpPr>
         <p:spPr>
           <a:xfrm>
-            <a:off x="8128000" y="1841500"/>
-            <a:ext cx="3556000" cy="2032000"/>
+            <a:off x="8128000" y="2133600"/>
+            <a:ext cx="3556000" cy="2438400"/>
           </a:xfrm>
           <a:prstGeom prst="roundRect">
             <a:avLst>
-              <a:gd name="adj" fmla="val 8750"/>
+              <a:gd name="adj" fmla="val 7291"/>
             </a:avLst>
           </a:prstGeom>
           <a:solidFill>
@@ -7504,23 +7679,23 @@
         </p:nvSpPr>
         <p:spPr>
           <a:xfrm>
-            <a:off x="8407400" y="2140590"/>
-            <a:ext cx="1738848" cy="853440"/>
-          </a:xfrm>
-          <a:prstGeom prst="rect">
-            <a:avLst/>
-          </a:prstGeom>
-          <a:noFill/>
-        </p:spPr>
-        <p:txBody>
-          <a:bodyPr wrap="none" lIns="0" rIns="0" tIns="0" bIns="0" anchor="t">
-            <a:noAutofit/>
-          </a:bodyPr>
-          <a:lstStyle/>
-          <a:p>
-            <a:pPr algn="l"/>
-            <a:r>
-              <a:rPr sz="4800" b="1">
+            <a:off x="8407400" y="2539106"/>
+            <a:ext cx="1883752" cy="924560"/>
+          </a:xfrm>
+          <a:prstGeom prst="rect">
+            <a:avLst/>
+          </a:prstGeom>
+          <a:noFill/>
+        </p:spPr>
+        <p:txBody>
+          <a:bodyPr wrap="none" lIns="0" rIns="0" tIns="0" bIns="0" anchor="t">
+            <a:noAutofit/>
+          </a:bodyPr>
+          <a:lstStyle/>
+          <a:p>
+            <a:pPr algn="l"/>
+            <a:r>
+              <a:rPr sz="5200" b="1">
                 <a:solidFill>
                   <a:srgbClr val="EF3124"/>
                 </a:solidFill>
@@ -7539,7 +7714,7 @@
         </p:nvSpPr>
         <p:spPr>
           <a:xfrm>
-            <a:off x="9869388" y="2519959"/>
+            <a:off x="9983812" y="2964459"/>
             <a:ext cx="529158" cy="266700"/>
           </a:xfrm>
           <a:prstGeom prst="rect">
@@ -7574,7 +7749,7 @@
         </p:nvCxnSpPr>
         <p:spPr>
           <a:xfrm>
-            <a:off x="8407400" y="3009900"/>
+            <a:off x="8407400" y="3505200"/>
             <a:ext cx="2997200" cy="0"/>
           </a:xfrm>
           <a:prstGeom prst="line">
@@ -7609,7 +7784,7 @@
         </p:nvSpPr>
         <p:spPr>
           <a:xfrm>
-            <a:off x="8407400" y="3128355"/>
+            <a:off x="8407400" y="3649055"/>
             <a:ext cx="2386132" cy="248920"/>
           </a:xfrm>
           <a:prstGeom prst="rect">
@@ -7644,7 +7819,7 @@
         </p:nvSpPr>
         <p:spPr>
           <a:xfrm>
-            <a:off x="8407400" y="3369655"/>
+            <a:off x="8407400" y="3903055"/>
             <a:ext cx="2495607" cy="248920"/>
           </a:xfrm>
           <a:prstGeom prst="rect">
@@ -7668,469 +7843,12 @@
               </a:rPr>
               <a:t>среднего и крупного бизнеса</a:t>
             </a:r>
-          </a:p>
-        </p:txBody>
-      </p:sp>
-      <p:sp>
-        <p:nvSpPr>
-          <p:cNvPr id="23" name="Rounded Rectangle 22"/>
-          <p:cNvSpPr/>
-          <p:nvPr/>
-        </p:nvSpPr>
-        <p:spPr>
-          <a:xfrm>
-            <a:off x="508000" y="4191000"/>
-            <a:ext cx="11176000" cy="1905000"/>
-          </a:xfrm>
-          <a:prstGeom prst="roundRect">
-            <a:avLst>
-              <a:gd name="adj" fmla="val 9333"/>
-            </a:avLst>
-          </a:prstGeom>
-          <a:solidFill>
-            <a:srgbClr val="FDF2F1"/>
-          </a:solidFill>
-          <a:ln>
-            <a:noFill/>
-          </a:ln>
-          <a:effectLst/>
-        </p:spPr>
-        <p:style>
-          <a:lnRef idx="1">
-            <a:schemeClr val="accent1"/>
-          </a:lnRef>
-          <a:fillRef idx="3">
-            <a:schemeClr val="accent1"/>
-          </a:fillRef>
-          <a:effectRef idx="2">
-            <a:schemeClr val="accent1"/>
-          </a:effectRef>
-          <a:fontRef idx="minor">
-            <a:schemeClr val="lt1"/>
-          </a:fontRef>
-        </p:style>
-        <p:txBody>
-          <a:bodyPr rtlCol="0" anchor="ctr" wrap="none"/>
-          <a:lstStyle/>
-          <a:p>
-            <a:pPr algn="ctr"/>
-          </a:p>
-        </p:txBody>
-      </p:sp>
-      <p:sp>
-        <p:nvSpPr>
-          <p:cNvPr id="24" name="Freeform 23"/>
-          <p:cNvSpPr/>
-          <p:nvPr/>
-        </p:nvSpPr>
-        <p:spPr>
-          <a:xfrm>
-            <a:off x="10346846" y="5585347"/>
-            <a:ext cx="1335135" cy="487324"/>
-          </a:xfrm>
-          <a:custGeom>
-            <a:avLst/>
-            <a:gdLst/>
-            <a:ahLst/>
-            <a:cxnLst/>
-            <a:rect l="l" t="t" r="r" b="b"/>
-            <a:pathLst>
-              <a:path w="1335135" h="487324">
-                <a:moveTo>
-                  <a:pt x="0" y="487324"/>
-                </a:moveTo>
-                <a:lnTo>
-                  <a:pt x="60297" y="456144"/>
-                </a:lnTo>
-                <a:lnTo>
-                  <a:pt x="120986" y="425734"/>
-                </a:lnTo>
-                <a:lnTo>
-                  <a:pt x="182057" y="396098"/>
-                </a:lnTo>
-                <a:lnTo>
-                  <a:pt x="243501" y="367243"/>
-                </a:lnTo>
-                <a:lnTo>
-                  <a:pt x="305307" y="339171"/>
-                </a:lnTo>
-                <a:lnTo>
-                  <a:pt x="367465" y="311888"/>
-                </a:lnTo>
-                <a:lnTo>
-                  <a:pt x="429965" y="285399"/>
-                </a:lnTo>
-                <a:lnTo>
-                  <a:pt x="492797" y="259707"/>
-                </a:lnTo>
-                <a:lnTo>
-                  <a:pt x="555951" y="234817"/>
-                </a:lnTo>
-                <a:lnTo>
-                  <a:pt x="619416" y="210732"/>
-                </a:lnTo>
-                <a:lnTo>
-                  <a:pt x="683184" y="187457"/>
-                </a:lnTo>
-                <a:lnTo>
-                  <a:pt x="747242" y="164995"/>
-                </a:lnTo>
-                <a:lnTo>
-                  <a:pt x="811580" y="143351"/>
-                </a:lnTo>
-                <a:lnTo>
-                  <a:pt x="876189" y="122527"/>
-                </a:lnTo>
-                <a:lnTo>
-                  <a:pt x="941058" y="102527"/>
-                </a:lnTo>
-                <a:lnTo>
-                  <a:pt x="1006176" y="83354"/>
-                </a:lnTo>
-                <a:lnTo>
-                  <a:pt x="1071533" y="65011"/>
-                </a:lnTo>
-                <a:lnTo>
-                  <a:pt x="1137118" y="47501"/>
-                </a:lnTo>
-                <a:lnTo>
-                  <a:pt x="1202920" y="30828"/>
-                </a:lnTo>
-                <a:lnTo>
-                  <a:pt x="1268929" y="14993"/>
-                </a:lnTo>
-                <a:lnTo>
-                  <a:pt x="1335135" y="0"/>
-                </a:lnTo>
-              </a:path>
-            </a:pathLst>
-          </a:custGeom>
-          <a:noFill/>
-          <a:ln w="12700">
-            <a:solidFill>
-              <a:srgbClr val="F0A79E">
-                <a:alpha val="38000"/>
-              </a:srgbClr>
-            </a:solidFill>
-          </a:ln>
-          <a:effectLst/>
-        </p:spPr>
-        <p:style>
-          <a:lnRef idx="1">
-            <a:schemeClr val="accent1"/>
-          </a:lnRef>
-          <a:fillRef idx="3">
-            <a:schemeClr val="accent1"/>
-          </a:fillRef>
-          <a:effectRef idx="2">
-            <a:schemeClr val="accent1"/>
-          </a:effectRef>
-          <a:fontRef idx="minor">
-            <a:schemeClr val="lt1"/>
-          </a:fontRef>
-        </p:style>
-        <p:txBody>
-          <a:bodyPr rtlCol="0" anchor="ctr"/>
-          <a:lstStyle/>
-          <a:p>
-            <a:pPr algn="ctr"/>
-          </a:p>
-        </p:txBody>
-      </p:sp>
-      <p:sp>
-        <p:nvSpPr>
-          <p:cNvPr id="25" name="Freeform 24"/>
-          <p:cNvSpPr/>
-          <p:nvPr/>
-        </p:nvSpPr>
-        <p:spPr>
-          <a:xfrm>
-            <a:off x="9330478" y="4809735"/>
-            <a:ext cx="2339879" cy="991714"/>
-          </a:xfrm>
-          <a:custGeom>
-            <a:avLst/>
-            <a:gdLst/>
-            <a:ahLst/>
-            <a:cxnLst/>
-            <a:rect l="l" t="t" r="r" b="b"/>
-            <a:pathLst>
-              <a:path w="2339879" h="991714">
-                <a:moveTo>
-                  <a:pt x="0" y="991714"/>
-                </a:moveTo>
-                <a:lnTo>
-                  <a:pt x="63831" y="947622"/>
-                </a:lnTo>
-                <a:lnTo>
-                  <a:pt x="128218" y="904345"/>
-                </a:lnTo>
-                <a:lnTo>
-                  <a:pt x="193151" y="861892"/>
-                </a:lnTo>
-                <a:lnTo>
-                  <a:pt x="258619" y="820268"/>
-                </a:lnTo>
-                <a:lnTo>
-                  <a:pt x="324611" y="779480"/>
-                </a:lnTo>
-                <a:lnTo>
-                  <a:pt x="391116" y="739536"/>
-                </a:lnTo>
-                <a:lnTo>
-                  <a:pt x="458125" y="700441"/>
-                </a:lnTo>
-                <a:lnTo>
-                  <a:pt x="525626" y="662203"/>
-                </a:lnTo>
-                <a:lnTo>
-                  <a:pt x="593608" y="624826"/>
-                </a:lnTo>
-                <a:lnTo>
-                  <a:pt x="662060" y="588318"/>
-                </a:lnTo>
-                <a:lnTo>
-                  <a:pt x="730971" y="552683"/>
-                </a:lnTo>
-                <a:lnTo>
-                  <a:pt x="800330" y="517929"/>
-                </a:lnTo>
-                <a:lnTo>
-                  <a:pt x="870126" y="484060"/>
-                </a:lnTo>
-                <a:lnTo>
-                  <a:pt x="940347" y="451082"/>
-                </a:lnTo>
-                <a:lnTo>
-                  <a:pt x="1010982" y="419000"/>
-                </a:lnTo>
-                <a:lnTo>
-                  <a:pt x="1082020" y="387820"/>
-                </a:lnTo>
-                <a:lnTo>
-                  <a:pt x="1153448" y="357546"/>
-                </a:lnTo>
-                <a:lnTo>
-                  <a:pt x="1225257" y="328184"/>
-                </a:lnTo>
-                <a:lnTo>
-                  <a:pt x="1297433" y="299738"/>
-                </a:lnTo>
-                <a:lnTo>
-                  <a:pt x="1369965" y="272212"/>
-                </a:lnTo>
-                <a:lnTo>
-                  <a:pt x="1442841" y="245612"/>
-                </a:lnTo>
-                <a:lnTo>
-                  <a:pt x="1516051" y="219942"/>
-                </a:lnTo>
-                <a:lnTo>
-                  <a:pt x="1589581" y="195205"/>
-                </a:lnTo>
-                <a:lnTo>
-                  <a:pt x="1663419" y="171406"/>
-                </a:lnTo>
-                <a:lnTo>
-                  <a:pt x="1737555" y="148549"/>
-                </a:lnTo>
-                <a:lnTo>
-                  <a:pt x="1811976" y="126637"/>
-                </a:lnTo>
-                <a:lnTo>
-                  <a:pt x="1886669" y="105674"/>
-                </a:lnTo>
-                <a:lnTo>
-                  <a:pt x="1961623" y="85663"/>
-                </a:lnTo>
-                <a:lnTo>
-                  <a:pt x="2036826" y="66608"/>
-                </a:lnTo>
-                <a:lnTo>
-                  <a:pt x="2112265" y="48511"/>
-                </a:lnTo>
-                <a:lnTo>
-                  <a:pt x="2187928" y="31376"/>
-                </a:lnTo>
-                <a:lnTo>
-                  <a:pt x="2263804" y="15205"/>
-                </a:lnTo>
-                <a:lnTo>
-                  <a:pt x="2339879" y="0"/>
-                </a:lnTo>
-              </a:path>
-            </a:pathLst>
-          </a:custGeom>
-          <a:noFill/>
-          <a:ln w="12700">
-            <a:solidFill>
-              <a:srgbClr val="F0A79E">
-                <a:alpha val="38000"/>
-              </a:srgbClr>
-            </a:solidFill>
-          </a:ln>
-          <a:effectLst/>
-        </p:spPr>
-        <p:style>
-          <a:lnRef idx="1">
-            <a:schemeClr val="accent1"/>
-          </a:lnRef>
-          <a:fillRef idx="3">
-            <a:schemeClr val="accent1"/>
-          </a:fillRef>
-          <a:effectRef idx="2">
-            <a:schemeClr val="accent1"/>
-          </a:effectRef>
-          <a:fontRef idx="minor">
-            <a:schemeClr val="lt1"/>
-          </a:fontRef>
-        </p:style>
-        <p:txBody>
-          <a:bodyPr rtlCol="0" anchor="ctr"/>
-          <a:lstStyle/>
-          <a:p>
-            <a:pPr algn="ctr"/>
-          </a:p>
-        </p:txBody>
-      </p:sp>
-      <p:sp>
-        <p:nvSpPr>
-          <p:cNvPr id="26" name="Freeform 25"/>
-          <p:cNvSpPr/>
-          <p:nvPr/>
-        </p:nvSpPr>
-        <p:spPr>
-          <a:xfrm>
-            <a:off x="8893413" y="4204044"/>
-            <a:ext cx="2038472" cy="973211"/>
-          </a:xfrm>
-          <a:custGeom>
-            <a:avLst/>
-            <a:gdLst/>
-            <a:ahLst/>
-            <a:cxnLst/>
-            <a:rect l="l" t="t" r="r" b="b"/>
-            <a:pathLst>
-              <a:path w="2038472" h="973211">
-                <a:moveTo>
-                  <a:pt x="0" y="973211"/>
-                </a:moveTo>
-                <a:lnTo>
-                  <a:pt x="71810" y="923607"/>
-                </a:lnTo>
-                <a:lnTo>
-                  <a:pt x="144245" y="874921"/>
-                </a:lnTo>
-                <a:lnTo>
-                  <a:pt x="217295" y="827161"/>
-                </a:lnTo>
-                <a:lnTo>
-                  <a:pt x="290946" y="780334"/>
-                </a:lnTo>
-                <a:lnTo>
-                  <a:pt x="365187" y="734448"/>
-                </a:lnTo>
-                <a:lnTo>
-                  <a:pt x="440006" y="689511"/>
-                </a:lnTo>
-                <a:lnTo>
-                  <a:pt x="515390" y="645530"/>
-                </a:lnTo>
-                <a:lnTo>
-                  <a:pt x="591329" y="602511"/>
-                </a:lnTo>
-                <a:lnTo>
-                  <a:pt x="667809" y="560462"/>
-                </a:lnTo>
-                <a:lnTo>
-                  <a:pt x="744817" y="519390"/>
-                </a:lnTo>
-                <a:lnTo>
-                  <a:pt x="822342" y="479302"/>
-                </a:lnTo>
-                <a:lnTo>
-                  <a:pt x="900371" y="440203"/>
-                </a:lnTo>
-                <a:lnTo>
-                  <a:pt x="978891" y="402100"/>
-                </a:lnTo>
-                <a:lnTo>
-                  <a:pt x="1057890" y="365000"/>
-                </a:lnTo>
-                <a:lnTo>
-                  <a:pt x="1137355" y="328908"/>
-                </a:lnTo>
-                <a:lnTo>
-                  <a:pt x="1217272" y="293830"/>
-                </a:lnTo>
-                <a:lnTo>
-                  <a:pt x="1297629" y="259772"/>
-                </a:lnTo>
-                <a:lnTo>
-                  <a:pt x="1378413" y="226739"/>
-                </a:lnTo>
-                <a:lnTo>
-                  <a:pt x="1459611" y="194738"/>
-                </a:lnTo>
-                <a:lnTo>
-                  <a:pt x="1541210" y="163772"/>
-                </a:lnTo>
-                <a:lnTo>
-                  <a:pt x="1623196" y="133847"/>
-                </a:lnTo>
-                <a:lnTo>
-                  <a:pt x="1705557" y="104968"/>
-                </a:lnTo>
-                <a:lnTo>
-                  <a:pt x="1788278" y="77139"/>
-                </a:lnTo>
-                <a:lnTo>
-                  <a:pt x="1871347" y="50365"/>
-                </a:lnTo>
-                <a:lnTo>
-                  <a:pt x="1954749" y="24651"/>
-                </a:lnTo>
-                <a:lnTo>
-                  <a:pt x="2038472" y="0"/>
-                </a:lnTo>
-              </a:path>
-            </a:pathLst>
-          </a:custGeom>
-          <a:noFill/>
-          <a:ln w="12700">
-            <a:solidFill>
-              <a:srgbClr val="F0A79E">
-                <a:alpha val="38000"/>
-              </a:srgbClr>
-            </a:solidFill>
-          </a:ln>
-          <a:effectLst/>
-        </p:spPr>
-        <p:style>
-          <a:lnRef idx="1">
-            <a:schemeClr val="accent1"/>
-          </a:lnRef>
-          <a:fillRef idx="3">
-            <a:schemeClr val="accent1"/>
-          </a:fillRef>
-          <a:effectRef idx="2">
-            <a:schemeClr val="accent1"/>
-          </a:effectRef>
-          <a:fontRef idx="minor">
-            <a:schemeClr val="lt1"/>
-          </a:fontRef>
-        </p:style>
-        <p:txBody>
-          <a:bodyPr rtlCol="0" anchor="ctr"/>
-          <a:lstStyle/>
-          <a:p>
-            <a:pPr algn="ctr"/>
           </a:p>
         </p:txBody>
       </p:sp>
       <p:pic>
         <p:nvPicPr>
-          <p:cNvPr id="27" name="Picture 26" descr="trophy.png"/>
+          <p:cNvPr id="23" name="Picture 22" descr="gem.png"/>
           <p:cNvPicPr>
             <a:picLocks noChangeAspect="1"/>
           </p:cNvPicPr>
@@ -8144,227 +7862,17 @@
         </p:blipFill>
         <p:spPr>
           <a:xfrm>
-            <a:off x="965200" y="4660900"/>
-            <a:ext cx="965200" cy="965200"/>
+            <a:off x="9982200" y="4902200"/>
+            <a:ext cx="1600200" cy="1260389"/>
           </a:xfrm>
           <a:prstGeom prst="rect">
             <a:avLst/>
           </a:prstGeom>
         </p:spPr>
       </p:pic>
-      <p:cxnSp>
-        <p:nvCxnSpPr>
-          <p:cNvPr id="28" name="Connector 27"/>
-          <p:cNvCxnSpPr/>
-          <p:nvPr/>
-        </p:nvCxnSpPr>
-        <p:spPr>
-          <a:xfrm>
-            <a:off x="2324100" y="4635500"/>
-            <a:ext cx="0" cy="1016000"/>
-          </a:xfrm>
-          <a:prstGeom prst="line">
-            <a:avLst/>
-          </a:prstGeom>
-          <a:ln w="6350">
-            <a:solidFill>
-              <a:srgbClr val="F3CCC7"/>
-            </a:solidFill>
-          </a:ln>
-        </p:spPr>
-        <p:style>
-          <a:lnRef idx="2">
-            <a:schemeClr val="accent1"/>
-          </a:lnRef>
-          <a:fillRef idx="0">
-            <a:schemeClr val="accent1"/>
-          </a:fillRef>
-          <a:effectRef idx="1">
-            <a:schemeClr val="accent1"/>
-          </a:effectRef>
-          <a:fontRef idx="minor">
-            <a:schemeClr val="tx1"/>
-          </a:fontRef>
-        </p:style>
-      </p:cxnSp>
-      <p:sp>
-        <p:nvSpPr>
-          <p:cNvPr id="29" name="TextBox 28"/>
-          <p:cNvSpPr txBox="1"/>
-          <p:nvPr/>
-        </p:nvSpPr>
-        <p:spPr>
-          <a:xfrm>
-            <a:off x="2730500" y="4749140"/>
-            <a:ext cx="573403" cy="177800"/>
-          </a:xfrm>
-          <a:prstGeom prst="rect">
-            <a:avLst/>
-          </a:prstGeom>
-          <a:noFill/>
-        </p:spPr>
-        <p:txBody>
-          <a:bodyPr wrap="none" lIns="0" rIns="0" tIns="0" bIns="0" anchor="t">
-            <a:noAutofit/>
-          </a:bodyPr>
-          <a:lstStyle/>
-          <a:p>
-            <a:pPr algn="l"/>
-            <a:r>
-              <a:rPr sz="1000" b="1" spc="140">
-                <a:solidFill>
-                  <a:srgbClr val="EF3124"/>
-                </a:solidFill>
-                <a:latin typeface="Arial"/>
-              </a:rPr>
-              <a:t>А ЕЩЁ</a:t>
-            </a:r>
-          </a:p>
-        </p:txBody>
-      </p:sp>
-      <p:sp>
-        <p:nvSpPr>
-          <p:cNvPr id="30" name="TextBox 29"/>
-          <p:cNvSpPr txBox="1"/>
-          <p:nvPr/>
-        </p:nvSpPr>
-        <p:spPr>
-          <a:xfrm>
-            <a:off x="2730500" y="5008382"/>
-            <a:ext cx="1325233" cy="817880"/>
-          </a:xfrm>
-          <a:prstGeom prst="rect">
-            <a:avLst/>
-          </a:prstGeom>
-          <a:noFill/>
-        </p:spPr>
-        <p:txBody>
-          <a:bodyPr wrap="none" lIns="0" rIns="0" tIns="0" bIns="0" anchor="t">
-            <a:noAutofit/>
-          </a:bodyPr>
-          <a:lstStyle/>
-          <a:p>
-            <a:pPr algn="l"/>
-            <a:r>
-              <a:rPr sz="4600" b="1">
-                <a:solidFill>
-                  <a:srgbClr val="EF3124"/>
-                </a:solidFill>
-                <a:latin typeface="Arial"/>
-              </a:rPr>
-              <a:t>197</a:t>
-            </a:r>
-          </a:p>
-        </p:txBody>
-      </p:sp>
-      <p:sp>
-        <p:nvSpPr>
-          <p:cNvPr id="31" name="TextBox 30"/>
-          <p:cNvSpPr txBox="1"/>
-          <p:nvPr/>
-        </p:nvSpPr>
-        <p:spPr>
-          <a:xfrm>
-            <a:off x="3806813" y="5353263"/>
-            <a:ext cx="999609" cy="284480"/>
-          </a:xfrm>
-          <a:prstGeom prst="rect">
-            <a:avLst/>
-          </a:prstGeom>
-          <a:noFill/>
-        </p:spPr>
-        <p:txBody>
-          <a:bodyPr wrap="none" lIns="0" rIns="0" tIns="0" bIns="0" anchor="t">
-            <a:noAutofit/>
-          </a:bodyPr>
-          <a:lstStyle/>
-          <a:p>
-            <a:pPr algn="l"/>
-            <a:r>
-              <a:rPr sz="1600" b="1">
-                <a:solidFill>
-                  <a:srgbClr val="EF3124"/>
-                </a:solidFill>
-                <a:latin typeface="Arial"/>
-              </a:rPr>
-              <a:t>млн руб.</a:t>
-            </a:r>
-          </a:p>
-        </p:txBody>
-      </p:sp>
-      <p:sp>
-        <p:nvSpPr>
-          <p:cNvPr id="32" name="TextBox 31"/>
-          <p:cNvSpPr txBox="1"/>
-          <p:nvPr/>
-        </p:nvSpPr>
-        <p:spPr>
-          <a:xfrm>
-            <a:off x="5715000" y="4906289"/>
-            <a:ext cx="2660656" cy="266700"/>
-          </a:xfrm>
-          <a:prstGeom prst="rect">
-            <a:avLst/>
-          </a:prstGeom>
-          <a:noFill/>
-        </p:spPr>
-        <p:txBody>
-          <a:bodyPr wrap="none" lIns="0" rIns="0" tIns="0" bIns="0" anchor="t">
-            <a:noAutofit/>
-          </a:bodyPr>
-          <a:lstStyle/>
-          <a:p>
-            <a:pPr algn="l"/>
-            <a:r>
-              <a:rPr sz="1500" b="0">
-                <a:solidFill>
-                  <a:srgbClr val="1D1D1D"/>
-                </a:solidFill>
-                <a:latin typeface="Arial"/>
-              </a:rPr>
-              <a:t>заработали через запуск игр</a:t>
-            </a:r>
-          </a:p>
-        </p:txBody>
-      </p:sp>
-      <p:sp>
-        <p:nvSpPr>
-          <p:cNvPr id="33" name="TextBox 32"/>
-          <p:cNvSpPr txBox="1"/>
-          <p:nvPr/>
-        </p:nvSpPr>
-        <p:spPr>
-          <a:xfrm>
-            <a:off x="5715000" y="5172989"/>
-            <a:ext cx="1925352" cy="266700"/>
-          </a:xfrm>
-          <a:prstGeom prst="rect">
-            <a:avLst/>
-          </a:prstGeom>
-          <a:noFill/>
-        </p:spPr>
-        <p:txBody>
-          <a:bodyPr wrap="none" lIns="0" rIns="0" tIns="0" bIns="0" anchor="t">
-            <a:noAutofit/>
-          </a:bodyPr>
-          <a:lstStyle/>
-          <a:p>
-            <a:pPr algn="l"/>
-            <a:r>
-              <a:rPr sz="1500" b="0">
-                <a:solidFill>
-                  <a:srgbClr val="1D1D1D"/>
-                </a:solidFill>
-                <a:latin typeface="Arial"/>
-              </a:rPr>
-              <a:t>для Розницы и ММБ</a:t>
-            </a:r>
-          </a:p>
-        </p:txBody>
-      </p:sp>
-      <p:sp>
-        <p:nvSpPr>
-          <p:cNvPr id="34" name="TextBox 33"/>
+      <p:sp>
+        <p:nvSpPr>
+          <p:cNvPr id="24" name="TextBox 23"/>
           <p:cNvSpPr txBox="1"/>
           <p:nvPr/>
         </p:nvSpPr>

</xml_diff>